<commit_message>
docs: screenshots and deck from the live site, counters filled
Co-Authored-By: Claude Opus 5 <noreply@anthropic.com>
</commit_message>
<xml_diff>
--- a/docs/deck.pptx
+++ b/docs/deck.pptx
@@ -5925,7 +5925,7 @@
                 <a:ea typeface="Cambria" pitchFamily="34" charset="-122"/>
                 <a:cs typeface="Cambria" pitchFamily="34" charset="-120"/>
               </a:rPr>
-              <a:t>{{ROOTS}}</a:t>
+              <a:t>15</a:t>
             </a:r>
             <a:endParaRPr lang="en-US" sz="2200" dirty="0"/>
           </a:p>
@@ -6003,7 +6003,7 @@
                 <a:ea typeface="Cambria" pitchFamily="34" charset="-122"/>
                 <a:cs typeface="Cambria" pitchFamily="34" charset="-120"/>
               </a:rPr>
-              <a:t>{{HUMANS}}</a:t>
+              <a:t>600</a:t>
             </a:r>
             <a:endParaRPr lang="en-US" sz="2200" dirty="0"/>
           </a:p>
@@ -6042,7 +6042,7 @@
                 <a:ea typeface="Calibri" pitchFamily="34" charset="-122"/>
                 <a:cs typeface="Calibri" pitchFamily="34" charset="-120"/>
               </a:rPr>
-              <a:t>humans in the registry</a:t>
+              <a:t>World ID identities carried</a:t>
             </a:r>
             <a:endParaRPr lang="en-US" sz="1000" dirty="0"/>
           </a:p>
@@ -6081,7 +6081,7 @@
                 <a:ea typeface="Cambria" pitchFamily="34" charset="-122"/>
                 <a:cs typeface="Cambria" pitchFamily="34" charset="-120"/>
               </a:rPr>
-              <a:t>{{CREDIT}}</a:t>
+              <a:t>1,000</a:t>
             </a:r>
             <a:endParaRPr lang="en-US" sz="2200" dirty="0"/>
           </a:p>
@@ -6120,7 +6120,7 @@
                 <a:ea typeface="Calibri" pitchFamily="34" charset="-122"/>
                 <a:cs typeface="Calibri" pitchFamily="34" charset="-120"/>
               </a:rPr>
-              <a:t>hUSD credit extended</a:t>
+              <a:t>hUSD in the lender pools</a:t>
             </a:r>
             <a:endParaRPr lang="en-US" sz="1000" dirty="0"/>
           </a:p>
@@ -6276,7 +6276,7 @@
                 <a:ea typeface="Courier New" pitchFamily="34" charset="-122"/>
                 <a:cs typeface="Courier New" pitchFamily="34" charset="-120"/>
               </a:rPr>
-              <a:t>{{LIVE_URL}}    ·    {{REPO_URL}}</a:t>
+              <a:t>https://humanline.credit    ·    https://github.com/rajkaria/humanline</a:t>
             </a:r>
             <a:endParaRPr lang="en-US" sz="1100" dirty="0"/>
           </a:p>
@@ -16663,7 +16663,7 @@
                 <a:ea typeface="Courier New" pitchFamily="34" charset="-122"/>
                 <a:cs typeface="Courier New" pitchFamily="34" charset="-120"/>
               </a:rPr>
-              <a:t>Live at {{LIVE_URL}}    ·    video at {{VIDEO_URL}}</a:t>
+              <a:t>Live at https://humanline.credit    ·    demo video linked from the submission</a:t>
             </a:r>
             <a:endParaRPr lang="en-US" sz="1100" dirty="0"/>
           </a:p>

</xml_diff>

<commit_message>
ocean(sp10): submission kit matches the deployed reality; deck rebuilt
- SUBMISSION: current addresses (CreditLine v2 on both profiles, RelayReward, HumanPoll; twelve
  Blockscout-verified contracts), description (255 words) and Attestcoin summary (347 words)
  rewritten around the 0x0FD4 credit ceiling, prover independence, live refusals and the SDK, a
  "what only Humanline does" table, and a checklist with today's test counts and the two
  maintainer actions (npm publish, video).
- VIDEO_SCRIPT: the attack beat shows the twelve live refusals on /judge and the CLI.
- DECK and deck-build.js: dated gallery numbers, the 0x0FD4 credit ceiling and local/browser proof
  checks on the depth slide, live refusals and /vote in the demo, a roadmap that reflects what is
  already built. deck.pptx and deck.pdf rebuilt.
- MEASUREMENTS: the register/delete calldata-length deletions are recorded as equivalent mutants.

Co-Authored-By: Claude Opus 5 <noreply@anthropic.com>
</commit_message>
<xml_diff>
--- a/docs/deck.pptx
+++ b/docs/deck.pptx
@@ -1512,7 +1512,7 @@
           <a:p>
             <a:r>
               <a:rPr lang="en-US" dirty="0"/>
-              <a:t>This is the scoring criterion. Ten surfaces, and every one is load-bearing.</a:t>
+              <a:t>This is the scoring criterion. Every surface is load-bearing, and the guards are exercised against the live deployment.</a:t>
             </a:r>
             <a:endParaRPr lang="en-US" dirty="0"/>
           </a:p>
@@ -4636,7 +4636,7 @@
                 <a:ea typeface="Calibri" pitchFamily="34" charset="-122"/>
                 <a:cs typeface="Calibri" pitchFamily="34" charset="-120"/>
               </a:rPr>
-              <a:t>AttestedWorldID and HumanRegistry on Creditcoin mainnet, published as a public read interface. First lender using isHuman as a sybil check through Credal. Two independent relayers.</a:t>
+              <a:t>AttestedWorldID and HumanRegistry on Creditcoin mainnet. Deploy the already-tested cross-chain contracts: Ethereum wallet links, Aave history, repay-from-Ethereum. First lender using isHuman through Credal.</a:t>
             </a:r>
             <a:endParaRPr lang="en-US" sz="1050" dirty="0"/>
           </a:p>
@@ -4808,7 +4808,7 @@
                 <a:ea typeface="Calibri" pitchFamily="34" charset="-122"/>
                 <a:cs typeface="Calibri" pitchFamily="34" charset="-120"/>
               </a:rPr>
-              <a:t>Lines funded by PenguinSwap LPs. Repay-from-Ethereum: a USDC transfer proven through Attestcoin and credited on Creditcoin. BSC as a source chain when chainKey 8 ships.</a:t>
+              <a:t>Lines funded by PenguinSwap LPs. More apps on HumanGated and the public API. BSC as a source chain when chainKey 8 ships.</a:t>
             </a:r>
             <a:endParaRPr lang="en-US" sz="1050" dirty="0"/>
           </a:p>
@@ -7219,7 +7219,7 @@
                 <a:ea typeface="Calibri" pitchFamily="34" charset="-122"/>
                 <a:cs typeface="Calibri" pitchFamily="34" charset="-120"/>
               </a:rPr>
-              <a:t>87 submissions in this hackathon. About 30 build the same thing.</a:t>
+              <a:t>87 submissions when we surveyed on 2026-09-12. About 30 built the same thing.</a:t>
             </a:r>
             <a:endParaRPr lang="en-US" sz="1300" dirty="0"/>
           </a:p>
@@ -12139,7 +12139,7 @@
                 <a:ea typeface="Cambria" pitchFamily="34" charset="-122"/>
                 <a:cs typeface="Cambria" pitchFamily="34" charset="-120"/>
               </a:rPr>
-              <a:t>Attestcoin depth: ten surfaces, all load-bearing</a:t>
+              <a:t>Attestcoin depth: every surface load-bearing</a:t>
             </a:r>
             <a:endParaRPr lang="en-US" sz="3400" dirty="0"/>
           </a:p>
@@ -12160,7 +12160,7 @@
           </p:nvPr>
         </p:nvGraphicFramePr>
         <p:xfrm>
-          <a:off x="566928" y="1463040"/>
+          <a:off x="566928" y="1417320"/>
           <a:ext cx="11057839" cy="914400"/>
         </p:xfrm>
         <a:graphic>
@@ -12172,7 +12172,7 @@
                 <a:gridCol w="3017520"/>
                 <a:gridCol w="5221224"/>
               </a:tblGrid>
-              <a:tr h="352044">
+              <a:tr h="329184">
                 <a:tc>
                   <a:txBody>
                     <a:bodyPr/>
@@ -12378,7 +12378,7 @@
                   </a:tcPr>
                 </a:tc>
               </a:tr>
-              <a:tr h="352044">
+              <a:tr h="329184">
                 <a:tc>
                   <a:txBody>
                     <a:bodyPr/>
@@ -12388,7 +12388,7 @@
                         <a:buNone/>
                       </a:pPr>
                       <a:r>
-                        <a:rPr lang="en-US" sz="1020" dirty="0">
+                        <a:rPr lang="en-US" sz="1000" dirty="0">
                           <a:solidFill>
                             <a:srgbClr val="94A3B8"/>
                           </a:solidFill>
@@ -12398,7 +12398,7 @@
                         </a:rPr>
                         <a:t>verifyAndEmit (0x0FD2)</a:t>
                       </a:r>
-                      <a:endParaRPr lang="en-US" sz="1020" dirty="0">
+                      <a:endParaRPr lang="en-US" sz="1000" dirty="0">
                         <a:latin typeface="Calibri" charset="0"/>
                         <a:ea typeface="Calibri" charset="0"/>
                         <a:cs typeface="Calibri" charset="0"/>
@@ -12456,7 +12456,7 @@
                         <a:buNone/>
                       </a:pPr>
                       <a:r>
-                        <a:rPr lang="en-US" sz="1020" dirty="0">
+                        <a:rPr lang="en-US" sz="1000" dirty="0">
                           <a:solidFill>
                             <a:srgbClr val="94A3B8"/>
                           </a:solidFill>
@@ -12466,7 +12466,7 @@
                         </a:rPr>
                         <a:t>ASCBase.execute</a:t>
                       </a:r>
-                      <a:endParaRPr lang="en-US" sz="1020" dirty="0">
+                      <a:endParaRPr lang="en-US" sz="1000" dirty="0">
                         <a:latin typeface="Calibri" charset="0"/>
                         <a:ea typeface="Calibri" charset="0"/>
                         <a:cs typeface="Calibri" charset="0"/>
@@ -12524,7 +12524,7 @@
                         <a:buNone/>
                       </a:pPr>
                       <a:r>
-                        <a:rPr lang="en-US" sz="1020" dirty="0">
+                        <a:rPr lang="en-US" sz="1000" dirty="0">
                           <a:solidFill>
                             <a:srgbClr val="94A3B8"/>
                           </a:solidFill>
@@ -12534,7 +12534,7 @@
                         </a:rPr>
                         <a:t>No root reaches the verifier without it</a:t>
                       </a:r>
-                      <a:endParaRPr lang="en-US" sz="1020" dirty="0">
+                      <a:endParaRPr lang="en-US" sz="1000" dirty="0">
                         <a:latin typeface="Calibri" charset="0"/>
                         <a:ea typeface="Calibri" charset="0"/>
                         <a:cs typeface="Calibri" charset="0"/>
@@ -12584,7 +12584,7 @@
                   </a:tcPr>
                 </a:tc>
               </a:tr>
-              <a:tr h="352044">
+              <a:tr h="329184">
                 <a:tc>
                   <a:txBody>
                     <a:bodyPr/>
@@ -12594,7 +12594,7 @@
                         <a:buNone/>
                       </a:pPr>
                       <a:r>
-                        <a:rPr lang="en-US" sz="1020" dirty="0">
+                        <a:rPr lang="en-US" sz="1000" dirty="0">
                           <a:solidFill>
                             <a:srgbClr val="94A3B8"/>
                           </a:solidFill>
@@ -12604,7 +12604,7 @@
                         </a:rPr>
                         <a:t>Batch verification</a:t>
                       </a:r>
-                      <a:endParaRPr lang="en-US" sz="1020" dirty="0">
+                      <a:endParaRPr lang="en-US" sz="1000" dirty="0">
                         <a:latin typeface="Calibri" charset="0"/>
                         <a:ea typeface="Calibri" charset="0"/>
                         <a:cs typeface="Calibri" charset="0"/>
@@ -12662,7 +12662,7 @@
                         <a:buNone/>
                       </a:pPr>
                       <a:r>
-                        <a:rPr lang="en-US" sz="1020" dirty="0">
+                        <a:rPr lang="en-US" sz="1000" dirty="0">
                           <a:solidFill>
                             <a:srgbClr val="94A3B8"/>
                           </a:solidFill>
@@ -12672,7 +12672,7 @@
                         </a:rPr>
                         <a:t>getBatchProof, executeBatch</a:t>
                       </a:r>
-                      <a:endParaRPr lang="en-US" sz="1020" dirty="0">
+                      <a:endParaRPr lang="en-US" sz="1000" dirty="0">
                         <a:latin typeface="Calibri" charset="0"/>
                         <a:ea typeface="Calibri" charset="0"/>
                         <a:cs typeface="Calibri" charset="0"/>
@@ -12730,7 +12730,7 @@
                         <a:buNone/>
                       </a:pPr>
                       <a:r>
-                        <a:rPr lang="en-US" sz="1020" dirty="0">
+                        <a:rPr lang="en-US" sz="1000" dirty="0">
                           <a:solidFill>
                             <a:srgbClr val="94A3B8"/>
                           </a:solidFill>
@@ -12740,7 +12740,7 @@
                         </a:rPr>
                         <a:t>Up to 10 proofs under one continuity proof</a:t>
                       </a:r>
-                      <a:endParaRPr lang="en-US" sz="1020" dirty="0">
+                      <a:endParaRPr lang="en-US" sz="1000" dirty="0">
                         <a:latin typeface="Calibri" charset="0"/>
                         <a:ea typeface="Calibri" charset="0"/>
                         <a:cs typeface="Calibri" charset="0"/>
@@ -12790,7 +12790,7 @@
                   </a:tcPr>
                 </a:tc>
               </a:tr>
-              <a:tr h="352044">
+              <a:tr h="329184">
                 <a:tc>
                   <a:txBody>
                     <a:bodyPr/>
@@ -12800,7 +12800,7 @@
                         <a:buNone/>
                       </a:pPr>
                       <a:r>
-                        <a:rPr lang="en-US" sz="1020" dirty="0">
+                        <a:rPr lang="en-US" sz="1000" dirty="0">
                           <a:solidFill>
                             <a:srgbClr val="94A3B8"/>
                           </a:solidFill>
@@ -12810,7 +12810,7 @@
                         </a:rPr>
                         <a:t>Calldata decoding</a:t>
                       </a:r>
-                      <a:endParaRPr lang="en-US" sz="1020" dirty="0">
+                      <a:endParaRPr lang="en-US" sz="1000" dirty="0">
                         <a:latin typeface="Calibri" charset="0"/>
                         <a:ea typeface="Calibri" charset="0"/>
                         <a:cs typeface="Calibri" charset="0"/>
@@ -12868,7 +12868,7 @@
                         <a:buNone/>
                       </a:pPr>
                       <a:r>
-                        <a:rPr lang="en-US" sz="1020" dirty="0">
+                        <a:rPr lang="en-US" sz="1000" dirty="0">
                           <a:solidFill>
                             <a:srgbClr val="94A3B8"/>
                           </a:solidFill>
@@ -12878,7 +12878,7 @@
                         </a:rPr>
                         <a:t>decodeCommonTxFields(tx).data</a:t>
                       </a:r>
-                      <a:endParaRPr lang="en-US" sz="1020" dirty="0">
+                      <a:endParaRPr lang="en-US" sz="1000" dirty="0">
                         <a:latin typeface="Calibri" charset="0"/>
                         <a:ea typeface="Calibri" charset="0"/>
                         <a:cs typeface="Calibri" charset="0"/>
@@ -12936,7 +12936,7 @@
                         <a:buNone/>
                       </a:pPr>
                       <a:r>
-                        <a:rPr lang="en-US" sz="1020" dirty="0">
+                        <a:rPr lang="en-US" sz="1000" dirty="0">
                           <a:solidFill>
                             <a:srgbClr val="94A3B8"/>
                           </a:solidFill>
@@ -12946,7 +12946,7 @@
                         </a:rPr>
                         <a:t>Yields postRoot and the count of humans added</a:t>
                       </a:r>
-                      <a:endParaRPr lang="en-US" sz="1020" dirty="0">
+                      <a:endParaRPr lang="en-US" sz="1000" dirty="0">
                         <a:latin typeface="Calibri" charset="0"/>
                         <a:ea typeface="Calibri" charset="0"/>
                         <a:cs typeface="Calibri" charset="0"/>
@@ -12996,7 +12996,7 @@
                   </a:tcPr>
                 </a:tc>
               </a:tr>
-              <a:tr h="352044">
+              <a:tr h="329184">
                 <a:tc>
                   <a:txBody>
                     <a:bodyPr/>
@@ -13006,7 +13006,7 @@
                         <a:buNone/>
                       </a:pPr>
                       <a:r>
-                        <a:rPr lang="en-US" sz="1020" dirty="0">
+                        <a:rPr lang="en-US" sz="1000" dirty="0">
                           <a:solidFill>
                             <a:srgbClr val="94A3B8"/>
                           </a:solidFill>
@@ -13016,7 +13016,7 @@
                         </a:rPr>
                         <a:t>Log decoding</a:t>
                       </a:r>
-                      <a:endParaRPr lang="en-US" sz="1020" dirty="0">
+                      <a:endParaRPr lang="en-US" sz="1000" dirty="0">
                         <a:latin typeface="Calibri" charset="0"/>
                         <a:ea typeface="Calibri" charset="0"/>
                         <a:cs typeface="Calibri" charset="0"/>
@@ -13074,7 +13074,7 @@
                         <a:buNone/>
                       </a:pPr>
                       <a:r>
-                        <a:rPr lang="en-US" sz="1020" dirty="0">
+                        <a:rPr lang="en-US" sz="1000" dirty="0">
                           <a:solidFill>
                             <a:srgbClr val="94A3B8"/>
                           </a:solidFill>
@@ -13084,7 +13084,7 @@
                         </a:rPr>
                         <a:t>getLogsByEventSignature</a:t>
                       </a:r>
-                      <a:endParaRPr lang="en-US" sz="1020" dirty="0">
+                      <a:endParaRPr lang="en-US" sz="1000" dirty="0">
                         <a:latin typeface="Calibri" charset="0"/>
                         <a:ea typeface="Calibri" charset="0"/>
                         <a:cs typeface="Calibri" charset="0"/>
@@ -13142,7 +13142,7 @@
                         <a:buNone/>
                       </a:pPr>
                       <a:r>
-                        <a:rPr lang="en-US" sz="1020" dirty="0">
+                        <a:rPr lang="en-US" sz="1000" dirty="0">
                           <a:solidFill>
                             <a:srgbClr val="94A3B8"/>
                           </a:solidFill>
@@ -13152,7 +13152,7 @@
                         </a:rPr>
                         <a:t>The root itself</a:t>
                       </a:r>
-                      <a:endParaRPr lang="en-US" sz="1020" dirty="0">
+                      <a:endParaRPr lang="en-US" sz="1000" dirty="0">
                         <a:latin typeface="Calibri" charset="0"/>
                         <a:ea typeface="Calibri" charset="0"/>
                         <a:cs typeface="Calibri" charset="0"/>
@@ -13202,7 +13202,7 @@
                   </a:tcPr>
                 </a:tc>
               </a:tr>
-              <a:tr h="352044">
+              <a:tr h="329184">
                 <a:tc>
                   <a:txBody>
                     <a:bodyPr/>
@@ -13212,7 +13212,7 @@
                         <a:buNone/>
                       </a:pPr>
                       <a:r>
-                        <a:rPr lang="en-US" sz="1020" dirty="0">
+                        <a:rPr lang="en-US" sz="1000" dirty="0">
                           <a:solidFill>
                             <a:srgbClr val="94A3B8"/>
                           </a:solidFill>
@@ -13222,7 +13222,7 @@
                         </a:rPr>
                         <a:t>Emitter and status binding</a:t>
                       </a:r>
-                      <a:endParaRPr lang="en-US" sz="1020" dirty="0">
+                      <a:endParaRPr lang="en-US" sz="1000" dirty="0">
                         <a:latin typeface="Calibri" charset="0"/>
                         <a:ea typeface="Calibri" charset="0"/>
                         <a:cs typeface="Calibri" charset="0"/>
@@ -13280,7 +13280,7 @@
                         <a:buNone/>
                       </a:pPr>
                       <a:r>
-                        <a:rPr lang="en-US" sz="1020" dirty="0">
+                        <a:rPr lang="en-US" sz="1000" dirty="0">
                           <a:solidFill>
                             <a:srgbClr val="94A3B8"/>
                           </a:solidFill>
@@ -13290,7 +13290,7 @@
                         </a:rPr>
                         <a:t>to, log.address_, status</a:t>
                       </a:r>
-                      <a:endParaRPr lang="en-US" sz="1020" dirty="0">
+                      <a:endParaRPr lang="en-US" sz="1000" dirty="0">
                         <a:latin typeface="Calibri" charset="0"/>
                         <a:ea typeface="Calibri" charset="0"/>
                         <a:cs typeface="Calibri" charset="0"/>
@@ -13348,7 +13348,7 @@
                         <a:buNone/>
                       </a:pPr>
                       <a:r>
-                        <a:rPr lang="en-US" sz="1020" dirty="0">
+                        <a:rPr lang="en-US" sz="1000" dirty="0">
                           <a:solidFill>
                             <a:srgbClr val="94A3B8"/>
                           </a:solidFill>
@@ -13358,7 +13358,7 @@
                         </a:rPr>
                         <a:t>Rejects look-alike events and reverted txs</a:t>
                       </a:r>
-                      <a:endParaRPr lang="en-US" sz="1020" dirty="0">
+                      <a:endParaRPr lang="en-US" sz="1000" dirty="0">
                         <a:latin typeface="Calibri" charset="0"/>
                         <a:ea typeface="Calibri" charset="0"/>
                         <a:cs typeface="Calibri" charset="0"/>
@@ -13408,7 +13408,7 @@
                   </a:tcPr>
                 </a:tc>
               </a:tr>
-              <a:tr h="352044">
+              <a:tr h="329184">
                 <a:tc>
                   <a:txBody>
                     <a:bodyPr/>
@@ -13418,7 +13418,7 @@
                         <a:buNone/>
                       </a:pPr>
                       <a:r>
-                        <a:rPr lang="en-US" sz="1020" dirty="0">
+                        <a:rPr lang="en-US" sz="1000" dirty="0">
                           <a:solidFill>
                             <a:srgbClr val="94A3B8"/>
                           </a:solidFill>
@@ -13428,7 +13428,7 @@
                         </a:rPr>
                         <a:t>calculateTxIndex</a:t>
                       </a:r>
-                      <a:endParaRPr lang="en-US" sz="1020" dirty="0">
+                      <a:endParaRPr lang="en-US" sz="1000" dirty="0">
                         <a:latin typeface="Calibri" charset="0"/>
                         <a:ea typeface="Calibri" charset="0"/>
                         <a:cs typeface="Calibri" charset="0"/>
@@ -13486,7 +13486,7 @@
                         <a:buNone/>
                       </a:pPr>
                       <a:r>
-                        <a:rPr lang="en-US" sz="1020" dirty="0">
+                        <a:rPr lang="en-US" sz="1000" dirty="0">
                           <a:solidFill>
                             <a:srgbClr val="94A3B8"/>
                           </a:solidFill>
@@ -13496,7 +13496,7 @@
                         </a:rPr>
                         <a:t>queryId, sourceTxIndex</a:t>
                       </a:r>
-                      <a:endParaRPr lang="en-US" sz="1020" dirty="0">
+                      <a:endParaRPr lang="en-US" sz="1000" dirty="0">
                         <a:latin typeface="Calibri" charset="0"/>
                         <a:ea typeface="Calibri" charset="0"/>
                         <a:cs typeface="Calibri" charset="0"/>
@@ -13554,7 +13554,7 @@
                         <a:buNone/>
                       </a:pPr>
                       <a:r>
-                        <a:rPr lang="en-US" sz="1020" dirty="0">
+                        <a:rPr lang="en-US" sz="1000" dirty="0">
                           <a:solidFill>
                             <a:srgbClr val="94A3B8"/>
                           </a:solidFill>
@@ -13564,7 +13564,7 @@
                         </a:rPr>
                         <a:t>Replay key and ordering evidence</a:t>
                       </a:r>
-                      <a:endParaRPr lang="en-US" sz="1020" dirty="0">
+                      <a:endParaRPr lang="en-US" sz="1000" dirty="0">
                         <a:latin typeface="Calibri" charset="0"/>
                         <a:ea typeface="Calibri" charset="0"/>
                         <a:cs typeface="Calibri" charset="0"/>
@@ -13614,7 +13614,7 @@
                   </a:tcPr>
                 </a:tc>
               </a:tr>
-              <a:tr h="352044">
+              <a:tr h="329184">
                 <a:tc>
                   <a:txBody>
                     <a:bodyPr/>
@@ -13624,7 +13624,7 @@
                         <a:buNone/>
                       </a:pPr>
                       <a:r>
-                        <a:rPr lang="en-US" sz="1020" dirty="0">
+                        <a:rPr lang="en-US" sz="1000" dirty="0">
                           <a:solidFill>
                             <a:srgbClr val="94A3B8"/>
                           </a:solidFill>
@@ -13634,7 +13634,7 @@
                         </a:rPr>
                         <a:t>ChainInfo (0x0FD3)</a:t>
                       </a:r>
-                      <a:endParaRPr lang="en-US" sz="1020" dirty="0">
+                      <a:endParaRPr lang="en-US" sz="1000" dirty="0">
                         <a:latin typeface="Calibri" charset="0"/>
                         <a:ea typeface="Calibri" charset="0"/>
                         <a:cs typeface="Calibri" charset="0"/>
@@ -13692,7 +13692,7 @@
                         <a:buNone/>
                       </a:pPr>
                       <a:r>
-                        <a:rPr lang="en-US" sz="1020" dirty="0">
+                        <a:rPr lang="en-US" sz="1000" dirty="0">
                           <a:solidFill>
                             <a:srgbClr val="94A3B8"/>
                           </a:solidFill>
@@ -13702,7 +13702,7 @@
                         </a:rPr>
                         <a:t>Finality depth guard</a:t>
                       </a:r>
-                      <a:endParaRPr lang="en-US" sz="1020" dirty="0">
+                      <a:endParaRPr lang="en-US" sz="1000" dirty="0">
                         <a:latin typeface="Calibri" charset="0"/>
                         <a:ea typeface="Calibri" charset="0"/>
                         <a:cs typeface="Calibri" charset="0"/>
@@ -13760,7 +13760,7 @@
                         <a:buNone/>
                       </a:pPr>
                       <a:r>
-                        <a:rPr lang="en-US" sz="1020" dirty="0">
+                        <a:rPr lang="en-US" sz="1000" dirty="0">
                           <a:solidFill>
                             <a:srgbClr val="94A3B8"/>
                           </a:solidFill>
@@ -13770,7 +13770,7 @@
                         </a:rPr>
                         <a:t>Accepted only 32 blocks behind the attested tip</a:t>
                       </a:r>
-                      <a:endParaRPr lang="en-US" sz="1020" dirty="0">
+                      <a:endParaRPr lang="en-US" sz="1000" dirty="0">
                         <a:latin typeface="Calibri" charset="0"/>
                         <a:ea typeface="Calibri" charset="0"/>
                         <a:cs typeface="Calibri" charset="0"/>
@@ -13820,7 +13820,7 @@
                   </a:tcPr>
                 </a:tc>
               </a:tr>
-              <a:tr h="352044">
+              <a:tr h="329184">
                 <a:tc>
                   <a:txBody>
                     <a:bodyPr/>
@@ -13830,7 +13830,7 @@
                         <a:buNone/>
                       </a:pPr>
                       <a:r>
-                        <a:rPr lang="en-US" sz="1020" dirty="0">
+                        <a:rPr lang="en-US" sz="1000" dirty="0">
                           <a:solidFill>
                             <a:srgbClr val="94A3B8"/>
                           </a:solidFill>
@@ -13840,7 +13840,7 @@
                         </a:rPr>
                         <a:t>AttestorStash (0x0FD4)</a:t>
                       </a:r>
-                      <a:endParaRPr lang="en-US" sz="1020" dirty="0">
+                      <a:endParaRPr lang="en-US" sz="1000" dirty="0">
                         <a:latin typeface="Calibri" charset="0"/>
                         <a:ea typeface="Calibri" charset="0"/>
                         <a:cs typeface="Calibri" charset="0"/>
@@ -13898,7 +13898,7 @@
                         <a:buNone/>
                       </a:pPr>
                       <a:r>
-                        <a:rPr lang="en-US" sz="1020" dirty="0">
+                        <a:rPr lang="en-US" sz="1000" dirty="0">
                           <a:solidFill>
                             <a:srgbClr val="94A3B8"/>
                           </a:solidFill>
@@ -13906,9 +13906,9 @@
                           <a:ea typeface="Calibri" pitchFamily="34" charset="-122"/>
                           <a:cs typeface="Calibri" pitchFamily="34" charset="-120"/>
                         </a:rPr>
-                        <a:t>Quorum floor</a:t>
+                        <a:t>Quorum floor, credit ceiling</a:t>
                       </a:r>
-                      <a:endParaRPr lang="en-US" sz="1020" dirty="0">
+                      <a:endParaRPr lang="en-US" sz="1000" dirty="0">
                         <a:latin typeface="Calibri" charset="0"/>
                         <a:ea typeface="Calibri" charset="0"/>
                         <a:cs typeface="Calibri" charset="0"/>
@@ -13966,7 +13966,7 @@
                         <a:buNone/>
                       </a:pPr>
                       <a:r>
-                        <a:rPr lang="en-US" sz="1020" dirty="0">
+                        <a:rPr lang="en-US" sz="1000" dirty="0">
                           <a:solidFill>
                             <a:srgbClr val="94A3B8"/>
                           </a:solidFill>
@@ -13974,9 +13974,9 @@
                           <a:ea typeface="Calibri" pitchFamily="34" charset="-122"/>
                           <a:cs typeface="Calibri" pitchFamily="34" charset="-120"/>
                         </a:rPr>
-                        <a:t>Refuses roots attested by a thin set</a:t>
+                        <a:t>Thin attestor sets refused; credit capped at bonded stake</a:t>
                       </a:r>
-                      <a:endParaRPr lang="en-US" sz="1020" dirty="0">
+                      <a:endParaRPr lang="en-US" sz="1000" dirty="0">
                         <a:latin typeface="Calibri" charset="0"/>
                         <a:ea typeface="Calibri" charset="0"/>
                         <a:cs typeface="Calibri" charset="0"/>
@@ -14026,7 +14026,7 @@
                   </a:tcPr>
                 </a:tc>
               </a:tr>
-              <a:tr h="352044">
+              <a:tr h="329184">
                 <a:tc>
                   <a:txBody>
                     <a:bodyPr/>
@@ -14036,7 +14036,7 @@
                         <a:buNone/>
                       </a:pPr>
                       <a:r>
-                        <a:rPr lang="en-US" sz="1020" dirty="0">
+                        <a:rPr lang="en-US" sz="1000" dirty="0">
                           <a:solidFill>
                             <a:srgbClr val="94A3B8"/>
                           </a:solidFill>
@@ -14046,7 +14046,7 @@
                         </a:rPr>
                         <a:t>Two source chains</a:t>
                       </a:r>
-                      <a:endParaRPr lang="en-US" sz="1020" dirty="0">
+                      <a:endParaRPr lang="en-US" sz="1000" dirty="0">
                         <a:latin typeface="Calibri" charset="0"/>
                         <a:ea typeface="Calibri" charset="0"/>
                         <a:cs typeface="Calibri" charset="0"/>
@@ -14104,7 +14104,7 @@
                         <a:buNone/>
                       </a:pPr>
                       <a:r>
-                        <a:rPr lang="en-US" sz="1020" dirty="0">
+                        <a:rPr lang="en-US" sz="1000" dirty="0">
                           <a:solidFill>
                             <a:srgbClr val="94A3B8"/>
                           </a:solidFill>
@@ -14114,7 +14114,7 @@
                         </a:rPr>
                         <a:t>chainKey 3 and chainKey 1</a:t>
                       </a:r>
-                      <a:endParaRPr lang="en-US" sz="1020" dirty="0">
+                      <a:endParaRPr lang="en-US" sz="1000" dirty="0">
                         <a:latin typeface="Calibri" charset="0"/>
                         <a:ea typeface="Calibri" charset="0"/>
                         <a:cs typeface="Calibri" charset="0"/>
@@ -14172,7 +14172,7 @@
                         <a:buNone/>
                       </a:pPr>
                       <a:r>
-                        <a:rPr lang="en-US" sz="1020" dirty="0">
+                        <a:rPr lang="en-US" sz="1000" dirty="0">
                           <a:solidFill>
                             <a:srgbClr val="94A3B8"/>
                           </a:solidFill>
@@ -14182,7 +14182,7 @@
                         </a:rPr>
                         <a:t>Production and judge-reproducible paths</a:t>
                       </a:r>
-                      <a:endParaRPr lang="en-US" sz="1020" dirty="0">
+                      <a:endParaRPr lang="en-US" sz="1000" dirty="0">
                         <a:latin typeface="Calibri" charset="0"/>
                         <a:ea typeface="Calibri" charset="0"/>
                         <a:cs typeface="Calibri" charset="0"/>
@@ -14232,7 +14232,7 @@
                   </a:tcPr>
                 </a:tc>
               </a:tr>
-              <a:tr h="352044">
+              <a:tr h="329184">
                 <a:tc>
                   <a:txBody>
                     <a:bodyPr/>
@@ -14242,7 +14242,7 @@
                         <a:buNone/>
                       </a:pPr>
                       <a:r>
-                        <a:rPr lang="en-US" sz="1020" dirty="0">
+                        <a:rPr lang="en-US" sz="1000" dirty="0">
                           <a:solidFill>
                             <a:srgbClr val="94A3B8"/>
                           </a:solidFill>
@@ -14252,7 +14252,7 @@
                         </a:rPr>
                         <a:t>Zero-knowledge on top</a:t>
                       </a:r>
-                      <a:endParaRPr lang="en-US" sz="1020" dirty="0">
+                      <a:endParaRPr lang="en-US" sz="1000" dirty="0">
                         <a:latin typeface="Calibri" charset="0"/>
                         <a:ea typeface="Calibri" charset="0"/>
                         <a:cs typeface="Calibri" charset="0"/>
@@ -14310,7 +14310,7 @@
                         <a:buNone/>
                       </a:pPr>
                       <a:r>
-                        <a:rPr lang="en-US" sz="1020" dirty="0">
+                        <a:rPr lang="en-US" sz="1000" dirty="0">
                           <a:solidFill>
                             <a:srgbClr val="94A3B8"/>
                           </a:solidFill>
@@ -14320,7 +14320,7 @@
                         </a:rPr>
                         <a:t>Semaphore over a relayed root</a:t>
                       </a:r>
-                      <a:endParaRPr lang="en-US" sz="1020" dirty="0">
+                      <a:endParaRPr lang="en-US" sz="1000" dirty="0">
                         <a:latin typeface="Calibri" charset="0"/>
                         <a:ea typeface="Calibri" charset="0"/>
                         <a:cs typeface="Calibri" charset="0"/>
@@ -14378,7 +14378,7 @@
                         <a:buNone/>
                       </a:pPr>
                       <a:r>
-                        <a:rPr lang="en-US" sz="1020" dirty="0">
+                        <a:rPr lang="en-US" sz="1000" dirty="0">
                           <a:solidFill>
                             <a:srgbClr val="94A3B8"/>
                           </a:solidFill>
@@ -14388,7 +14388,213 @@
                         </a:rPr>
                         <a:t>Without Attestcoin the verifier has no root</a:t>
                       </a:r>
-                      <a:endParaRPr lang="en-US" sz="1020" dirty="0">
+                      <a:endParaRPr lang="en-US" sz="1000" dirty="0">
+                        <a:latin typeface="Calibri" charset="0"/>
+                        <a:ea typeface="Calibri" charset="0"/>
+                        <a:cs typeface="Calibri" charset="0"/>
+                      </a:endParaRPr>
+                    </a:p>
+                  </a:txBody>
+                  <a:tcPr marL="54864" marR="54864" marT="54864" marB="54864" anchor="ctr">
+                    <a:lnL w="6350" cap="flat" cmpd="sng" algn="ctr">
+                      <a:solidFill>
+                        <a:srgbClr val="2A3448"/>
+                      </a:solidFill>
+                      <a:prstDash val="solid"/>
+                      <a:round/>
+                      <a:headEnd type="none" w="med" len="med"/>
+                      <a:tailEnd type="none" w="med" len="med"/>
+                    </a:lnL>
+                    <a:lnR w="6350" cap="flat" cmpd="sng" algn="ctr">
+                      <a:solidFill>
+                        <a:srgbClr val="2A3448"/>
+                      </a:solidFill>
+                      <a:prstDash val="solid"/>
+                      <a:round/>
+                      <a:headEnd type="none" w="med" len="med"/>
+                      <a:tailEnd type="none" w="med" len="med"/>
+                    </a:lnR>
+                    <a:lnT w="6350" cap="flat" cmpd="sng" algn="ctr">
+                      <a:solidFill>
+                        <a:srgbClr val="2A3448"/>
+                      </a:solidFill>
+                      <a:prstDash val="solid"/>
+                      <a:round/>
+                      <a:headEnd type="none" w="med" len="med"/>
+                      <a:tailEnd type="none" w="med" len="med"/>
+                    </a:lnT>
+                    <a:lnB w="6350" cap="flat" cmpd="sng" algn="ctr">
+                      <a:solidFill>
+                        <a:srgbClr val="2A3448"/>
+                      </a:solidFill>
+                      <a:prstDash val="solid"/>
+                      <a:round/>
+                      <a:headEnd type="none" w="med" len="med"/>
+                      <a:tailEnd type="none" w="med" len="med"/>
+                    </a:lnB>
+                    <a:solidFill>
+                      <a:srgbClr val="151C2A"/>
+                    </a:solidFill>
+                  </a:tcPr>
+                </a:tc>
+              </a:tr>
+              <a:tr h="329184">
+                <a:tc>
+                  <a:txBody>
+                    <a:bodyPr/>
+                    <a:lstStyle/>
+                    <a:p>
+                      <a:pPr indent="0" marL="0">
+                        <a:buNone/>
+                      </a:pPr>
+                      <a:r>
+                        <a:rPr lang="en-US" sz="1000" dirty="0">
+                          <a:solidFill>
+                            <a:srgbClr val="94A3B8"/>
+                          </a:solidFill>
+                          <a:latin typeface="Calibri" pitchFamily="34" charset="0"/>
+                          <a:ea typeface="Calibri" pitchFamily="34" charset="-122"/>
+                          <a:cs typeface="Calibri" pitchFamily="34" charset="-120"/>
+                        </a:rPr>
+                        <a:t>Local proofs, browser checks</a:t>
+                      </a:r>
+                      <a:endParaRPr lang="en-US" sz="1000" dirty="0">
+                        <a:latin typeface="Calibri" charset="0"/>
+                        <a:ea typeface="Calibri" charset="0"/>
+                        <a:cs typeface="Calibri" charset="0"/>
+                      </a:endParaRPr>
+                    </a:p>
+                  </a:txBody>
+                  <a:tcPr marL="54864" marR="54864" marT="54864" marB="54864" anchor="ctr">
+                    <a:lnL w="6350" cap="flat" cmpd="sng" algn="ctr">
+                      <a:solidFill>
+                        <a:srgbClr val="2A3448"/>
+                      </a:solidFill>
+                      <a:prstDash val="solid"/>
+                      <a:round/>
+                      <a:headEnd type="none" w="med" len="med"/>
+                      <a:tailEnd type="none" w="med" len="med"/>
+                    </a:lnL>
+                    <a:lnR w="6350" cap="flat" cmpd="sng" algn="ctr">
+                      <a:solidFill>
+                        <a:srgbClr val="2A3448"/>
+                      </a:solidFill>
+                      <a:prstDash val="solid"/>
+                      <a:round/>
+                      <a:headEnd type="none" w="med" len="med"/>
+                      <a:tailEnd type="none" w="med" len="med"/>
+                    </a:lnR>
+                    <a:lnT w="6350" cap="flat" cmpd="sng" algn="ctr">
+                      <a:solidFill>
+                        <a:srgbClr val="2A3448"/>
+                      </a:solidFill>
+                      <a:prstDash val="solid"/>
+                      <a:round/>
+                      <a:headEnd type="none" w="med" len="med"/>
+                      <a:tailEnd type="none" w="med" len="med"/>
+                    </a:lnT>
+                    <a:lnB w="6350" cap="flat" cmpd="sng" algn="ctr">
+                      <a:solidFill>
+                        <a:srgbClr val="2A3448"/>
+                      </a:solidFill>
+                      <a:prstDash val="solid"/>
+                      <a:round/>
+                      <a:headEnd type="none" w="med" len="med"/>
+                      <a:tailEnd type="none" w="med" len="med"/>
+                    </a:lnB>
+                    <a:solidFill>
+                      <a:srgbClr val="151C2A"/>
+                    </a:solidFill>
+                  </a:tcPr>
+                </a:tc>
+                <a:tc>
+                  <a:txBody>
+                    <a:bodyPr/>
+                    <a:lstStyle/>
+                    <a:p>
+                      <a:pPr indent="0" marL="0">
+                        <a:buNone/>
+                      </a:pPr>
+                      <a:r>
+                        <a:rPr lang="en-US" sz="1000" dirty="0">
+                          <a:solidFill>
+                            <a:srgbClr val="94A3B8"/>
+                          </a:solidFill>
+                          <a:latin typeface="Calibri" pitchFamily="34" charset="0"/>
+                          <a:ea typeface="Calibri" pitchFamily="34" charset="-122"/>
+                          <a:cs typeface="Calibri" pitchFamily="34" charset="-120"/>
+                        </a:rPr>
+                        <a:t>RawProofBuilder; fold vs ChainInfo</a:t>
+                      </a:r>
+                      <a:endParaRPr lang="en-US" sz="1000" dirty="0">
+                        <a:latin typeface="Calibri" charset="0"/>
+                        <a:ea typeface="Calibri" charset="0"/>
+                        <a:cs typeface="Calibri" charset="0"/>
+                      </a:endParaRPr>
+                    </a:p>
+                  </a:txBody>
+                  <a:tcPr marL="54864" marR="54864" marT="54864" marB="54864" anchor="ctr">
+                    <a:lnL w="6350" cap="flat" cmpd="sng" algn="ctr">
+                      <a:solidFill>
+                        <a:srgbClr val="2A3448"/>
+                      </a:solidFill>
+                      <a:prstDash val="solid"/>
+                      <a:round/>
+                      <a:headEnd type="none" w="med" len="med"/>
+                      <a:tailEnd type="none" w="med" len="med"/>
+                    </a:lnL>
+                    <a:lnR w="6350" cap="flat" cmpd="sng" algn="ctr">
+                      <a:solidFill>
+                        <a:srgbClr val="2A3448"/>
+                      </a:solidFill>
+                      <a:prstDash val="solid"/>
+                      <a:round/>
+                      <a:headEnd type="none" w="med" len="med"/>
+                      <a:tailEnd type="none" w="med" len="med"/>
+                    </a:lnR>
+                    <a:lnT w="6350" cap="flat" cmpd="sng" algn="ctr">
+                      <a:solidFill>
+                        <a:srgbClr val="2A3448"/>
+                      </a:solidFill>
+                      <a:prstDash val="solid"/>
+                      <a:round/>
+                      <a:headEnd type="none" w="med" len="med"/>
+                      <a:tailEnd type="none" w="med" len="med"/>
+                    </a:lnT>
+                    <a:lnB w="6350" cap="flat" cmpd="sng" algn="ctr">
+                      <a:solidFill>
+                        <a:srgbClr val="2A3448"/>
+                      </a:solidFill>
+                      <a:prstDash val="solid"/>
+                      <a:round/>
+                      <a:headEnd type="none" w="med" len="med"/>
+                      <a:tailEnd type="none" w="med" len="med"/>
+                    </a:lnB>
+                    <a:solidFill>
+                      <a:srgbClr val="151C2A"/>
+                    </a:solidFill>
+                  </a:tcPr>
+                </a:tc>
+                <a:tc>
+                  <a:txBody>
+                    <a:bodyPr/>
+                    <a:lstStyle/>
+                    <a:p>
+                      <a:pPr indent="0" marL="0">
+                        <a:buNone/>
+                      </a:pPr>
+                      <a:r>
+                        <a:rPr lang="en-US" sz="1000" dirty="0">
+                          <a:solidFill>
+                            <a:srgbClr val="94A3B8"/>
+                          </a:solidFill>
+                          <a:latin typeface="Calibri" pitchFamily="34" charset="0"/>
+                          <a:ea typeface="Calibri" pitchFamily="34" charset="-122"/>
+                          <a:cs typeface="Calibri" pitchFamily="34" charset="-120"/>
+                        </a:rPr>
+                        <a:t>No single prover; nothing unverified is signed</a:t>
+                      </a:r>
+                      <a:endParaRPr lang="en-US" sz="1000" dirty="0">
                         <a:latin typeface="Calibri" charset="0"/>
                         <a:ea typeface="Calibri" charset="0"/>
                         <a:cs typeface="Calibri" charset="0"/>
@@ -16413,7 +16619,7 @@
                 <a:ea typeface="Calibri" pitchFamily="34" charset="-122"/>
                 <a:cs typeface="Calibri" pitchFamily="34" charset="-120"/>
               </a:rPr>
-              <a:t>Run the negative-path suite live. Every attack rejected by a named error.</a:t>
+              <a:t>No wallet: twelve attacks fired at the deployed contracts as the page loads, each refused by name.</a:t>
             </a:r>
             <a:endParaRPr lang="en-US" sz="1050" dirty="0"/>
           </a:p>

</xml_diff>